<commit_message>
Set the AI-use share to 60-65% in the README and deck
The team's estimate replaces the drafted 85-90%. Removes the README TODO
and the deck speaker-note reminder. Deck rebuilt with build_deck.js and
exported to PDF with PowerPoint.

Co-Authored-By: Claude Opus 5.5 <noreply@anthropic.com>
</commit_message>
<xml_diff>
--- a/docs/pitch/JK_kavach_Deck.pptx
+++ b/docs/pitch/JK_kavach_Deck.pptx
@@ -1045,7 +1045,7 @@
             <a:r>
               <a:rPr lang="en-US" dirty="0"/>
               <a:t>I'm Ritik Bhardwaj, B.Tech IT at NIT Srinagar, a solo entry for J&amp;K. I framed the problem, made the design decisions, validated the results and own this pitch.
-AI-use disclosure, as the rules require: I built YatraKavach with Claude Code from Anthropic as a coding and research agent. It did the web research and the sourced research report, most of the code, tests and documentation, and an independent code review that found two real bugs. I chose the problem and the J&amp;K focus, set the requirements, approved every design decision and fix, and checked the results. My estimate: about 85-90% of the code and documents were generated by AI under my direction. [Confirm this share before submitting.]
+AI-use disclosure, as the rules require: I built YatraKavach with Claude Code from Anthropic as a coding and research agent. It did the web research and the sourced research report, most of the code, tests and documentation, and an independent code review that found two real bugs. I chose the problem and the J&amp;K focus, set the requirements, approved every design decision and fix, and checked the results. My estimate: about 60-65% of the code and documents were generated by AI under my direction.
 Data: OpenStreetMap (ODbL), Copernicus DEM via Open-Meteo, Open-Meteo rain (CC BY 4.0), DM-Count (MIT), Wikimedia Commons demo photos. Everything simulated is labelled SIMULATED.</a:t>
             </a:r>
             <a:endParaRPr lang="en-US" dirty="0"/>
@@ -7881,7 +7881,7 @@
                 <a:ea typeface="Calibri" pitchFamily="34" charset="-122"/>
                 <a:cs typeface="Calibri" pitchFamily="34" charset="-120"/>
               </a:rPr>
-              <a:t>about 85–90% of code and documents AI-generated under the team’s direction.</a:t>
+              <a:t>about 60–65% of code and documents AI-generated under the team’s direction.</a:t>
             </a:r>
             <a:endParaRPr lang="en-US" sz="1500" dirty="0"/>
           </a:p>

</xml_diff>